<commit_message>
Session 2: add primer questions to Fishbowl Discussion
- 6 primers ranging from low-stakes to personal so fishbowl has somewhere to start
- Render 'examples' field on PPTX slides as PROMPTS (also fixes Pressure Scenarios)
- Facilitator note: project primers, drop a new one in only when conversation stalls

Co-Authored-By: Claude Opus 4.6 <noreply@anthropic.com>
</commit_message>
<xml_diff>
--- a/assets/downloads/Session-2-Your-Values-Under-Pressure.pptx
+++ b/assets/downloads/Session-2-Your-Values-Under-Pressure.pptx
@@ -5593,7 +5593,7 @@
         <p:spPr>
           <a:xfrm>
             <a:off x="731520" y="2560320"/>
-            <a:ext cx="10515600" cy="2743200"/>
+            <a:ext cx="10515600" cy="2011680"/>
           </a:xfrm>
           <a:prstGeom prst="rect">
             <a:avLst/>
@@ -5616,13 +5616,136 @@
             </a:pPr>
             <a:r>
               <a:t>4 scenarios appear on screen one at a time. For each, vote live: which value would you sacrifice first? Show results. Where the room splits, that's the discussion.</a:t>
+            </a:r>
+          </a:p>
+        </p:txBody>
+      </p:sp>
+      <p:sp>
+        <p:nvSpPr>
+          <p:cNvPr id="7" name="TextBox 6"/>
+          <p:cNvSpPr txBox="1"/>
+          <p:nvPr/>
+        </p:nvSpPr>
+        <p:spPr>
+          <a:xfrm>
+            <a:off x="731520" y="4663440"/>
+            <a:ext cx="10515600" cy="320040"/>
+          </a:xfrm>
+          <a:prstGeom prst="rect">
+            <a:avLst/>
+          </a:prstGeom>
+          <a:noFill/>
+        </p:spPr>
+        <p:txBody>
+          <a:bodyPr wrap="square" lIns="0" rIns="0">
+            <a:spAutoFit/>
+          </a:bodyPr>
+          <a:lstStyle/>
+          <a:p>
+            <a:pPr algn="l">
+              <a:defRPr sz="1100" b="1">
+                <a:solidFill>
+                  <a:srgbClr val="7B61FF"/>
+                </a:solidFill>
+                <a:latin typeface="Calibri"/>
+              </a:defRPr>
+            </a:pPr>
+            <a:r>
+              <a:t>PROMPTS</a:t>
+            </a:r>
+          </a:p>
+        </p:txBody>
+      </p:sp>
+      <p:sp>
+        <p:nvSpPr>
+          <p:cNvPr id="8" name="TextBox 7"/>
+          <p:cNvSpPr txBox="1"/>
+          <p:nvPr/>
+        </p:nvSpPr>
+        <p:spPr>
+          <a:xfrm>
+            <a:off x="731520" y="4983480"/>
+            <a:ext cx="10515600" cy="2103120"/>
+          </a:xfrm>
+          <a:prstGeom prst="rect">
+            <a:avLst/>
+          </a:prstGeom>
+          <a:noFill/>
+        </p:spPr>
+        <p:txBody>
+          <a:bodyPr wrap="square" lIns="0">
+            <a:spAutoFit/>
+          </a:bodyPr>
+          <a:lstStyle/>
+          <a:p>
+            <a:pPr>
+              <a:spcAft>
+                <a:spcPts val="800"/>
+              </a:spcAft>
+              <a:defRPr sz="1300">
+                <a:solidFill>
+                  <a:srgbClr val="B8B8D0"/>
+                </a:solidFill>
+                <a:latin typeface="Calibri"/>
+              </a:defRPr>
+            </a:pPr>
+            <a:r>
+              <a:t>•  Half the group isn't engaging. You have 5 minutes left. Do you push on or change the plan?</a:t>
+            </a:r>
+          </a:p>
+          <a:p>
+            <a:pPr>
+              <a:spcAft>
+                <a:spcPts val="800"/>
+              </a:spcAft>
+              <a:defRPr sz="1300">
+                <a:solidFill>
+                  <a:srgbClr val="B8B8D0"/>
+                </a:solidFill>
+                <a:latin typeface="Calibri"/>
+              </a:defRPr>
+            </a:pPr>
+            <a:r>
+              <a:t>•  A young person says something offensive in the chat. Do you delete it, address it publicly, or message them privately?</a:t>
+            </a:r>
+          </a:p>
+          <a:p>
+            <a:pPr>
+              <a:spcAft>
+                <a:spcPts val="800"/>
+              </a:spcAft>
+              <a:defRPr sz="1300">
+                <a:solidFill>
+                  <a:srgbClr val="B8B8D0"/>
+                </a:solidFill>
+                <a:latin typeface="Calibri"/>
+              </a:defRPr>
+            </a:pPr>
+            <a:r>
+              <a:t>•  The Wi-Fi goes down mid-session. You have 20 young people looking at you. What do you do?</a:t>
+            </a:r>
+          </a:p>
+          <a:p>
+            <a:pPr>
+              <a:spcAft>
+                <a:spcPts val="800"/>
+              </a:spcAft>
+              <a:defRPr sz="1300">
+                <a:solidFill>
+                  <a:srgbClr val="B8B8D0"/>
+                </a:solidFill>
+                <a:latin typeface="Calibri"/>
+              </a:defRPr>
+            </a:pPr>
+            <a:r>
+              <a:t>•  Two participants are dominating. Others have gone silent. Do you intervene or let it play out?</a:t>
             </a:r>
           </a:p>
         </p:txBody>
       </p:sp>
       <p:pic>
         <p:nvPicPr>
-          <p:cNvPr id="7" name="Picture 6" descr="logo.png"/>
+          <p:cNvPr id="9" name="Picture 8" descr="logo.png"/>
           <p:cNvPicPr>
             <a:picLocks noChangeAspect="1"/>
           </p:cNvPicPr>
@@ -5646,7 +5769,7 @@
       </p:pic>
       <p:sp>
         <p:nvSpPr>
-          <p:cNvPr id="8" name="TextBox 7"/>
+          <p:cNvPr id="10" name="TextBox 9"/>
           <p:cNvSpPr txBox="1"/>
           <p:nvPr/>
         </p:nvSpPr>
@@ -7897,7 +8020,7 @@
         <p:spPr>
           <a:xfrm>
             <a:off x="731520" y="2103120"/>
-            <a:ext cx="10515600" cy="2743200"/>
+            <a:ext cx="10515600" cy="2011680"/>
           </a:xfrm>
           <a:prstGeom prst="rect">
             <a:avLst/>
@@ -7919,14 +8042,169 @@
               </a:defRPr>
             </a:pPr>
             <a:r>
-              <a:t>4 chairs in the middle of the room. Volunteers sit and discuss: 'When is it OK to compromise your values in youth work?' Anyone can tap a shoulder to swap in. Everyone else listens in silence.</a:t>
+              <a:t>4 chairs in the middle of the room. Volunteers sit and discuss. Anyone can tap a shoulder to swap in. Everyone else listens in silence. Use the primers below to get going — pick whichever one hits hardest, or move through them as the conversation opens up.</a:t>
+            </a:r>
+          </a:p>
+        </p:txBody>
+      </p:sp>
+      <p:sp>
+        <p:nvSpPr>
+          <p:cNvPr id="6" name="TextBox 5"/>
+          <p:cNvSpPr txBox="1"/>
+          <p:nvPr/>
+        </p:nvSpPr>
+        <p:spPr>
+          <a:xfrm>
+            <a:off x="731520" y="4206240"/>
+            <a:ext cx="10515600" cy="320040"/>
+          </a:xfrm>
+          <a:prstGeom prst="rect">
+            <a:avLst/>
+          </a:prstGeom>
+          <a:noFill/>
+        </p:spPr>
+        <p:txBody>
+          <a:bodyPr wrap="square" lIns="0" rIns="0">
+            <a:spAutoFit/>
+          </a:bodyPr>
+          <a:lstStyle/>
+          <a:p>
+            <a:pPr algn="l">
+              <a:defRPr sz="1100" b="1">
+                <a:solidFill>
+                  <a:srgbClr val="FFB800"/>
+                </a:solidFill>
+                <a:latin typeface="Calibri"/>
+              </a:defRPr>
+            </a:pPr>
+            <a:r>
+              <a:t>PROMPTS</a:t>
+            </a:r>
+          </a:p>
+        </p:txBody>
+      </p:sp>
+      <p:sp>
+        <p:nvSpPr>
+          <p:cNvPr id="7" name="TextBox 6"/>
+          <p:cNvSpPr txBox="1"/>
+          <p:nvPr/>
+        </p:nvSpPr>
+        <p:spPr>
+          <a:xfrm>
+            <a:off x="731520" y="4526280"/>
+            <a:ext cx="10515600" cy="2103120"/>
+          </a:xfrm>
+          <a:prstGeom prst="rect">
+            <a:avLst/>
+          </a:prstGeom>
+          <a:noFill/>
+        </p:spPr>
+        <p:txBody>
+          <a:bodyPr wrap="square" lIns="0">
+            <a:spAutoFit/>
+          </a:bodyPr>
+          <a:lstStyle/>
+          <a:p>
+            <a:pPr>
+              <a:spcAft>
+                <a:spcPts val="800"/>
+              </a:spcAft>
+              <a:defRPr sz="1300">
+                <a:solidFill>
+                  <a:srgbClr val="B8B8D0"/>
+                </a:solidFill>
+                <a:latin typeface="Calibri"/>
+              </a:defRPr>
+            </a:pPr>
+            <a:r>
+              <a:t>•  When is it OK to compromise your values in youth work — and when isn't it?</a:t>
+            </a:r>
+          </a:p>
+          <a:p>
+            <a:pPr>
+              <a:spcAft>
+                <a:spcPts val="800"/>
+              </a:spcAft>
+              <a:defRPr sz="1300">
+                <a:solidFill>
+                  <a:srgbClr val="B8B8D0"/>
+                </a:solidFill>
+                <a:latin typeface="Calibri"/>
+              </a:defRPr>
+            </a:pPr>
+            <a:r>
+              <a:t>•  Name a time you stayed silent when you should have spoken up. What stopped you?</a:t>
+            </a:r>
+          </a:p>
+          <a:p>
+            <a:pPr>
+              <a:spcAft>
+                <a:spcPts val="800"/>
+              </a:spcAft>
+              <a:defRPr sz="1300">
+                <a:solidFill>
+                  <a:srgbClr val="B8B8D0"/>
+                </a:solidFill>
+                <a:latin typeface="Calibri"/>
+              </a:defRPr>
+            </a:pPr>
+            <a:r>
+              <a:t>•  Have you ever picked the tool that was easy over the tool that was right? What happened?</a:t>
+            </a:r>
+          </a:p>
+          <a:p>
+            <a:pPr>
+              <a:spcAft>
+                <a:spcPts val="800"/>
+              </a:spcAft>
+              <a:defRPr sz="1300">
+                <a:solidFill>
+                  <a:srgbClr val="B8B8D0"/>
+                </a:solidFill>
+                <a:latin typeface="Calibri"/>
+              </a:defRPr>
+            </a:pPr>
+            <a:r>
+              <a:t>•  If a young person asked you 'do you actually believe this?' about something you're running — could you answer honestly?</a:t>
+            </a:r>
+          </a:p>
+          <a:p>
+            <a:pPr>
+              <a:spcAft>
+                <a:spcPts val="800"/>
+              </a:spcAft>
+              <a:defRPr sz="1300">
+                <a:solidFill>
+                  <a:srgbClr val="B8B8D0"/>
+                </a:solidFill>
+                <a:latin typeface="Calibri"/>
+              </a:defRPr>
+            </a:pPr>
+            <a:r>
+              <a:t>•  What's a value your org says loudly that you've quietly stopped believing in?</a:t>
+            </a:r>
+          </a:p>
+          <a:p>
+            <a:pPr>
+              <a:spcAft>
+                <a:spcPts val="800"/>
+              </a:spcAft>
+              <a:defRPr sz="1300">
+                <a:solidFill>
+                  <a:srgbClr val="B8B8D0"/>
+                </a:solidFill>
+                <a:latin typeface="Calibri"/>
+              </a:defRPr>
+            </a:pPr>
+            <a:r>
+              <a:t>•  When your values clash with your manager's, whose win — and why?</a:t>
             </a:r>
           </a:p>
         </p:txBody>
       </p:sp>
       <p:pic>
         <p:nvPicPr>
-          <p:cNvPr id="6" name="Picture 5" descr="logo.png"/>
+          <p:cNvPr id="8" name="Picture 7" descr="logo.png"/>
           <p:cNvPicPr>
             <a:picLocks noChangeAspect="1"/>
           </p:cNvPicPr>
@@ -7950,7 +8228,7 @@
       </p:pic>
       <p:sp>
         <p:nvSpPr>
-          <p:cNvPr id="7" name="TextBox 6"/>
+          <p:cNvPr id="9" name="TextBox 8"/>
           <p:cNvSpPr txBox="1"/>
           <p:nvPr/>
         </p:nvSpPr>

</xml_diff>